<commit_message>
feat(rpl): integrate academic Agile methodology (XP, Scrum, DSDM), update presentation slides, and refresh blueprint PDF
</commit_message>
<xml_diff>
--- a/public/KostKu_Slide_Presentasi_Sidang_RPL.pptx
+++ b/public/KostKu_Slide_Presentasi_Sidang_RPL.pptx
@@ -22,6 +22,8 @@
     <p:sldId id="270" r:id="rId22"/>
     <p:sldId id="271" r:id="rId23"/>
     <p:sldId id="272" r:id="rId24"/>
+    <p:sldId id="273" r:id="rId25"/>
+    <p:sldId id="274" r:id="rId26"/>
   </p:sldIdLst>
   <p:sldSz cx="12191695" cy="6858000" type="screen4x3"/>
   <p:notesSz cx="6858000" cy="9144000"/>
@@ -872,12 +874,12 @@
           <a:lstStyle/>
           <a:p>
             <a:r>
-              <a:t>【 SLIDE 12 】 SOP Maintenance, Server Down &amp; Komplain Pengguna</a:t>
-            </a:r>
-          </a:p>
-          <a:p>
-            <a:r>
-              <a:t>Tag: ⚙️ STANDAR OPERASIONAL PROSEDUR</a:t>
+              <a:t>【 SLIDE 12 】 Implementasi Scrum Framework pada Siklus KostKu</a:t>
+            </a:r>
+          </a:p>
+          <a:p>
+            <a:r>
+              <a:t>Tag: 🔄 METODOLOGI SOFTWARE PROSES</a:t>
             </a:r>
           </a:p>
           <a:p/>
@@ -888,25 +890,13 @@
           </a:p>
           <a:p>
             <a:r>
-              <a:t>Untuk menjamin ketersediaan sistem dan kepuasan pengguna di tingkat enterprise, KostKu menetapkan 3 pilar Standar Operasional Prosedur (SOP) baku:</a:t>
-            </a:r>
-          </a:p>
-          <a:p/>
-          <a:p>
-            <a:r>
-              <a:t>Pertama, SOP Maintenance Terjadwal: Pemeliharaan server hanya dilakukan di jam sepi antara pukul 01.00 hingga 04.00 pagi, didahului banner pengumuman 24 jam dan full backup database.</a:t>
-            </a:r>
-          </a:p>
-          <a:p/>
-          <a:p>
-            <a:r>
-              <a:t>Kedua, SOP Tanggap Darurat Server Down: Dilengkapi monitoring otomatis, failover ke halaman statis dalam waktu kurang dari 5 menit, dan prosedur rollback cepat di bawah 15 menit jika terdeteksi regresi rilis.</a:t>
-            </a:r>
-          </a:p>
-          <a:p/>
-          <a:p>
-            <a:r>
-              <a:t>Ketiga, SOP Penanganan Komplain: Memiliki matriks SLA ketat, di mana komplain mendesak terkait keuangan atau akses kamar wajib direspons dalam 15 hingga 30 menit melalui siklus 3 langkah terstandarisasi.</a:t>
+              <a:t>Untuk merekayasa perangkat lunak KostKu secara adaptif dan terukur, kami memilih metodologi Agile dengan Framework Scrum yang diperkaya praktik rekayasa Extreme Programming.</a:t>
+            </a:r>
+          </a:p>
+          <a:p/>
+          <a:p>
+            <a:r>
+              <a:t>Dengan siklus Sprint 2 minggu, kami mampu merilis fungsionalitas produk bertahap—mulai dari MVP marketplace denah 2D, kalkulator utilitas, hingga AI Room Scanner. Daily Scrum menjaga sinkronisasi tim lintas-fungsi, sementara Definition of Done menjamin setiap kode yang dihasilkan bebas bug sebelum digabungkan.</a:t>
             </a:r>
           </a:p>
           <a:p/>
@@ -917,17 +907,17 @@
           </a:p>
           <a:p>
             <a:r>
-              <a:t>• Gestur: Tunjukkan sikap bertanggung jawab dan profesional dalam tata kelola sistem.</a:t>
-            </a:r>
-          </a:p>
-          <a:p>
-            <a:r>
-              <a:t>• Pointer: Tunjukkan target SLA 15-30 menit untuk komplain mendesak.</a:t>
-            </a:r>
-          </a:p>
-          <a:p>
-            <a:r>
-              <a:t>• Penekanan: Tekan kata 'Full Backup Pra-Maintenance' dan 'Zero Data Loss'.</a:t>
+              <a:t>• Gestur: Gerakan tangan berputar membentuk lingkaran untuk menggambarkan siklus Sprint 2 minggu.</a:t>
+            </a:r>
+          </a:p>
+          <a:p>
+            <a:r>
+              <a:t>• Pointer: Sorot urutan Sprint 1 hingga 4 lalu tunjukkan klausul Definition of Done.</a:t>
+            </a:r>
+          </a:p>
+          <a:p>
+            <a:r>
+              <a:t>• Penekanan: Tekan kata 'Rapid Feedback Loop' dan 'Sinergi Scrum dengan Praktik XP'.</a:t>
             </a:r>
           </a:p>
           <a:p/>
@@ -998,12 +988,12 @@
           <a:lstStyle/>
           <a:p>
             <a:r>
-              <a:t>【 SLIDE 13 】 KostKu: Platform Manajemen &amp; Marketplace Kost Pintar</a:t>
-            </a:r>
-          </a:p>
-          <a:p>
-            <a:r>
-              <a:t>Tag: 💖 KESIMPULAN &amp; PENUTUP</a:t>
+              <a:t>【 SLIDE 13 】 Komparasi Teori Model Agile: XP vs Scrum vs DSDM</a:t>
+            </a:r>
+          </a:p>
+          <a:p>
+            <a:r>
+              <a:t>Tag: 📚 LANDASAN TEORI AGILE</a:t>
             </a:r>
           </a:p>
           <a:p/>
@@ -1014,7 +1004,19 @@
           </a:p>
           <a:p>
             <a:r>
-              <a:t>Sekian pemaparan presentasi dari kami mengenai arsitektur, inovasi teknis, model bisnis, dan standar operasional prosedur KostKu. Kami siap mendemonstrasikan sistem secara langsung dan membuka sesi tanya-jawab kepada Bapak dan Ibu Penguji. Terima kasih banyak!</a:t>
+              <a:t>Sebagai landasan ilmiah teoritis, kami membedah tiga model Agile utama dalam rekayasa perangkat lunak: Extreme Programming, Scrum, dan DSDM.</a:t>
+            </a:r>
+          </a:p>
+          <a:p/>
+          <a:p>
+            <a:r>
+              <a:t>XP berfokus ekstrem pada keunggulan teknis penulisan kode melalui TDD dan Pair Programming. Scrum berfokus pada manajemen empiris dan fleksibilitas tim melalui wadah Sprint dan akuntabilitas peran. Sedangkan DSDM berfokus pada tata kelola bisnis korporat dengan mengunci waktu dan biaya serta memvariasikan fitur menggunakan metode MoSCoW.</a:t>
+            </a:r>
+          </a:p>
+          <a:p/>
+          <a:p>
+            <a:r>
+              <a:t>KostKu mensintesis keunggulan Scrum sebagai payung manajerial dan mengadopsi disiplin XP untuk kualitas kodenya.</a:t>
             </a:r>
           </a:p>
           <a:p/>
@@ -1025,17 +1027,17 @@
           </a:p>
           <a:p>
             <a:r>
-              <a:t>• Tersenyum ramah dan penuh percaya diri.</a:t>
-            </a:r>
-          </a:p>
-          <a:p>
-            <a:r>
-              <a:t>• Buka laptop / HP untuk mendemonstrasikan aplikasi secara live jika diminta.</a:t>
-            </a:r>
-          </a:p>
-          <a:p>
-            <a:r>
-              <a:t>• Persiapkan diri membuka slide panduan Q&amp;A jika dosen mengajukan pertanyaan kritis.</a:t>
+              <a:t>• Gestur: Tunjukkan perbandingan 3 kolom secara seimbang dari kiri ke kanan.</a:t>
+            </a:r>
+          </a:p>
+          <a:p>
+            <a:r>
+              <a:t>• Pointer: Sorot perbedaan fokus: XP (Engineering) vs Scrum (Management) vs DSDM (Business Governance).</a:t>
+            </a:r>
+          </a:p>
+          <a:p>
+            <a:r>
+              <a:t>• Penekanan: Tekan kesimpulan 'Sintesis terbaik: Scrum sebagai manajemen, XP sebagai disiplin kode'.</a:t>
             </a:r>
           </a:p>
           <a:p/>
@@ -1106,12 +1108,12 @@
           <a:lstStyle/>
           <a:p>
             <a:r>
-              <a:t>【 SLIDE 14 】 Kenapa Denah 2D SVG, Bukan Foto 360 / Virtual Tour?</a:t>
-            </a:r>
-          </a:p>
-          <a:p>
-            <a:r>
-              <a:t>Tag: 🛡️ PERTAHANAN Q&amp;A #1</a:t>
+              <a:t>【 SLIDE 14 】 SOP Maintenance, Server Down &amp; Komplain Pengguna</a:t>
+            </a:r>
+          </a:p>
+          <a:p>
+            <a:r>
+              <a:t>Tag: ⚙️ STANDAR OPERASIONAL PROSEDUR</a:t>
             </a:r>
           </a:p>
           <a:p/>
@@ -1122,10 +1124,48 @@
           </a:p>
           <a:p>
             <a:r>
-              <a:t>Jika penguji bertanya: 'Kenapa tidak memakai 360 Virtual Tour seperti Matterport?', sampaikan 3 pilar: Bandwidth (&lt;15KB vs 50MB), Presisi Skala (1:50 tanpa distorsi lensa cembung), dan Maintenance (cukup edit atribut JSON tanpa biaya foto ulang).</a:t>
-            </a:r>
-          </a:p>
-          <a:p/>
+              <a:t>Untuk menjamin ketersediaan sistem dan kepuasan pengguna di tingkat enterprise, KostKu menetapkan 3 pilar Standar Operasional Prosedur (SOP) baku:</a:t>
+            </a:r>
+          </a:p>
+          <a:p/>
+          <a:p>
+            <a:r>
+              <a:t>Pertama, SOP Maintenance Terjadwal: Pemeliharaan server hanya dilakukan di jam sepi antara pukul 01.00 hingga 04.00 pagi, didahului banner pengumuman 24 jam dan full backup database.</a:t>
+            </a:r>
+          </a:p>
+          <a:p/>
+          <a:p>
+            <a:r>
+              <a:t>Kedua, SOP Tanggap Darurat Server Down: Dilengkapi monitoring otomatis, failover ke halaman statis dalam waktu kurang dari 5 menit, dan prosedur rollback cepat di bawah 15 menit jika terdeteksi regresi rilis.</a:t>
+            </a:r>
+          </a:p>
+          <a:p/>
+          <a:p>
+            <a:r>
+              <a:t>Ketiga, SOP Penanganan Komplain: Memiliki matriks SLA ketat, di mana komplain mendesak terkait keuangan atau akses kamar wajib direspons dalam 15 hingga 30 menit melalui siklus 3 langkah terstandarisasi.</a:t>
+            </a:r>
+          </a:p>
+          <a:p/>
+          <a:p>
+            <a:r>
+              <a:t>--- TIPS GESTUR &amp; TEKNIS SIDANG ---</a:t>
+            </a:r>
+          </a:p>
+          <a:p>
+            <a:r>
+              <a:t>• Gestur: Tunjukkan sikap bertanggung jawab dan profesional dalam tata kelola sistem.</a:t>
+            </a:r>
+          </a:p>
+          <a:p>
+            <a:r>
+              <a:t>• Pointer: Tunjukkan target SLA 15-30 menit untuk komplain mendesak.</a:t>
+            </a:r>
+          </a:p>
+          <a:p>
+            <a:r>
+              <a:t>• Penekanan: Tekan kata 'Full Backup Pra-Maintenance' dan 'Zero Data Loss'.</a:t>
+            </a:r>
+          </a:p>
           <a:p/>
         </p:txBody>
       </p:sp>
@@ -1194,12 +1234,12 @@
           <a:lstStyle/>
           <a:p>
             <a:r>
-              <a:t>【 SLIDE 15 】 Kenapa Arsitektur Local-First, Bukan Full Cloud?</a:t>
-            </a:r>
-          </a:p>
-          <a:p>
-            <a:r>
-              <a:t>Tag: 🛡️ PERTAHANAN Q&amp;A #2</a:t>
+              <a:t>【 SLIDE 15 】 KostKu: Platform Manajemen &amp; Marketplace Kost Pintar</a:t>
+            </a:r>
+          </a:p>
+          <a:p>
+            <a:r>
+              <a:t>Tag: 💖 KESIMPULAN &amp; PENUTUP</a:t>
             </a:r>
           </a:p>
           <a:p/>
@@ -1210,10 +1250,30 @@
           </a:p>
           <a:p>
             <a:r>
-              <a:t>Jika penguji bertanya: 'Mengapa memilih SQLite lokal daripada Full Cloud Database terpusat?', sampaikan: 1. Zero-offline latency di area blank spot, 2. Penghematan biaya cloud compute hingga 80%, 3. Kedaulatan data sensitif pemilik kos terjamin.</a:t>
-            </a:r>
-          </a:p>
-          <a:p/>
+              <a:t>Sekian pemaparan presentasi dari kami mengenai arsitektur, inovasi teknis, model bisnis, metodologi Agile Scrum, dan standar operasional prosedur KostKu. Kami siap mendemonstrasikan sistem secara langsung dan membuka sesi tanya-jawab kepada Bapak dan Ibu Penguji. Terima kasih banyak!</a:t>
+            </a:r>
+          </a:p>
+          <a:p/>
+          <a:p>
+            <a:r>
+              <a:t>--- TIPS GESTUR &amp; TEKNIS SIDANG ---</a:t>
+            </a:r>
+          </a:p>
+          <a:p>
+            <a:r>
+              <a:t>• Tersenyum ramah dan penuh percaya diri.</a:t>
+            </a:r>
+          </a:p>
+          <a:p>
+            <a:r>
+              <a:t>• Buka laptop / HP untuk mendemonstrasikan aplikasi secara live jika diminta.</a:t>
+            </a:r>
+          </a:p>
+          <a:p>
+            <a:r>
+              <a:t>• Persiapkan diri membuka slide panduan Q&amp;A jika dosen mengajukan pertanyaan kritis.</a:t>
+            </a:r>
+          </a:p>
           <a:p/>
         </p:txBody>
       </p:sp>
@@ -1282,12 +1342,12 @@
           <a:lstStyle/>
           <a:p>
             <a:r>
-              <a:t>【 SLIDE 16 】 Kenapa 0% Komisi &amp; Direct WhatsApp? Rawan Ditinggalkan?</a:t>
-            </a:r>
-          </a:p>
-          <a:p>
-            <a:r>
-              <a:t>Tag: 🛡️ PERTAHANAN Q&amp;A #3</a:t>
+              <a:t>【 SLIDE 16 】 Kenapa Denah 2D SVG, Bukan Foto 360 / Virtual Tour?</a:t>
+            </a:r>
+          </a:p>
+          <a:p>
+            <a:r>
+              <a:t>Tag: 🛡️ PERTAHANAN Q&amp;A #1</a:t>
             </a:r>
           </a:p>
           <a:p/>
@@ -1298,7 +1358,7 @@
           </a:p>
           <a:p>
             <a:r>
-              <a:t>Jika penguji bertanya: 'Kenapa memberi kontak WhatsApp langsung? Bukankah platform rawan di-bypass?', sampaikan: Kami adalah SaaS perangkat lunak manajemen properti, bukan makelar komisi. 0% komisi justru menghilangkan niat pengguna untuk mem-bypass sistem dan menciptakan loyalitas retensi jangka panjang.</a:t>
+              <a:t>Jika penguji bertanya: 'Kenapa tidak memakai 360 Virtual Tour seperti Matterport?', sampaikan 3 pilar: Bandwidth (&lt;15KB vs 50MB), Presisi Skala (1:50 tanpa distorsi lensa cembung), dan Maintenance (cukup edit atribut JSON tanpa biaya foto ulang).</a:t>
             </a:r>
           </a:p>
           <a:p/>
@@ -1370,7 +1430,183 @@
           <a:lstStyle/>
           <a:p>
             <a:r>
-              <a:t>【 SLIDE 17 】 Bagaimana Prosedur Server Down &amp; Mitigasi Komplain?</a:t>
+              <a:t>【 SLIDE 17 】 Kenapa Arsitektur Local-First, Bukan Full Cloud?</a:t>
+            </a:r>
+          </a:p>
+          <a:p>
+            <a:r>
+              <a:t>Tag: 🛡️ PERTAHANAN Q&amp;A #2</a:t>
+            </a:r>
+          </a:p>
+          <a:p/>
+          <a:p>
+            <a:r>
+              <a:t>--- NASKAH PRESENTASI (APA YANG HARUS DIUCAPKAN) ---</a:t>
+            </a:r>
+          </a:p>
+          <a:p>
+            <a:r>
+              <a:t>Jika penguji bertanya: 'Mengapa memilih SQLite lokal daripada Full Cloud Database terpusat?', sampaikan: 1. Zero-offline latency di area blank spot, 2. Penghematan biaya cloud compute hingga 80%, 3. Kedaulatan data sensitif pemilik kos terjamin.</a:t>
+            </a:r>
+          </a:p>
+          <a:p/>
+          <a:p/>
+        </p:txBody>
+      </p:sp>
+      <p:sp>
+        <p:nvSpPr>
+          <p:cNvPr id="4" name="Slide Number Placeholder 3"/>
+          <p:cNvSpPr>
+            <a:spLocks noGrp="1"/>
+          </p:cNvSpPr>
+          <p:nvPr>
+            <p:ph type="sldNum" idx="5" sz="quarter"/>
+          </p:nvPr>
+        </p:nvSpPr>
+        <p:spPr/>
+      </p:sp>
+    </p:spTree>
+  </p:cSld>
+  <p:clrMapOvr>
+    <a:masterClrMapping/>
+  </p:clrMapOvr>
+</p:notes>
+</file>
+
+<file path=ppt/notesSlides/notesSlide18.xml><?xml version="1.0" encoding="utf-8"?>
+<p:notes xmlns:a="http://schemas.openxmlformats.org/drawingml/2006/main" xmlns:p="http://schemas.openxmlformats.org/presentationml/2006/main" xmlns:r="http://schemas.openxmlformats.org/officeDocument/2006/relationships">
+  <p:cSld>
+    <p:spTree>
+      <p:nvGrpSpPr>
+        <p:cNvPr id="1" name=""/>
+        <p:cNvGrpSpPr/>
+        <p:nvPr/>
+      </p:nvGrpSpPr>
+      <p:grpSpPr>
+        <a:xfrm>
+          <a:off x="0" y="0"/>
+          <a:ext cx="0" cy="0"/>
+          <a:chOff x="0" y="0"/>
+          <a:chExt cx="0" cy="0"/>
+        </a:xfrm>
+      </p:grpSpPr>
+      <p:sp>
+        <p:nvSpPr>
+          <p:cNvPr id="2" name="Slide Image Placeholder 1"/>
+          <p:cNvSpPr>
+            <a:spLocks noGrp="1"/>
+          </p:cNvSpPr>
+          <p:nvPr>
+            <p:ph type="sldImg" idx="2"/>
+          </p:nvPr>
+        </p:nvSpPr>
+        <p:spPr/>
+      </p:sp>
+      <p:sp>
+        <p:nvSpPr>
+          <p:cNvPr id="3" name="Notes Placeholder 2"/>
+          <p:cNvSpPr>
+            <a:spLocks noGrp="1"/>
+          </p:cNvSpPr>
+          <p:nvPr>
+            <p:ph type="body" idx="3" sz="quarter"/>
+          </p:nvPr>
+        </p:nvSpPr>
+        <p:spPr/>
+        <p:txBody>
+          <a:bodyPr/>
+          <a:lstStyle/>
+          <a:p>
+            <a:r>
+              <a:t>【 SLIDE 18 】 Kenapa 0% Komisi &amp; Direct WhatsApp? Rawan Ditinggalkan?</a:t>
+            </a:r>
+          </a:p>
+          <a:p>
+            <a:r>
+              <a:t>Tag: 🛡️ PERTAHANAN Q&amp;A #3</a:t>
+            </a:r>
+          </a:p>
+          <a:p/>
+          <a:p>
+            <a:r>
+              <a:t>--- NASKAH PRESENTASI (APA YANG HARUS DIUCAPKAN) ---</a:t>
+            </a:r>
+          </a:p>
+          <a:p>
+            <a:r>
+              <a:t>Jika penguji bertanya: 'Kenapa memberi kontak WhatsApp langsung? Bukankah platform rawan di-bypass?', sampaikan: Kami adalah SaaS perangkat lunak manajemen properti, bukan makelar komisi. 0% komisi justru menghilangkan niat pengguna untuk mem-bypass sistem dan menciptakan loyalitas retensi jangka panjang.</a:t>
+            </a:r>
+          </a:p>
+          <a:p/>
+          <a:p/>
+        </p:txBody>
+      </p:sp>
+      <p:sp>
+        <p:nvSpPr>
+          <p:cNvPr id="4" name="Slide Number Placeholder 3"/>
+          <p:cNvSpPr>
+            <a:spLocks noGrp="1"/>
+          </p:cNvSpPr>
+          <p:nvPr>
+            <p:ph type="sldNum" idx="5" sz="quarter"/>
+          </p:nvPr>
+        </p:nvSpPr>
+        <p:spPr/>
+      </p:sp>
+    </p:spTree>
+  </p:cSld>
+  <p:clrMapOvr>
+    <a:masterClrMapping/>
+  </p:clrMapOvr>
+</p:notes>
+</file>
+
+<file path=ppt/notesSlides/notesSlide19.xml><?xml version="1.0" encoding="utf-8"?>
+<p:notes xmlns:a="http://schemas.openxmlformats.org/drawingml/2006/main" xmlns:p="http://schemas.openxmlformats.org/presentationml/2006/main" xmlns:r="http://schemas.openxmlformats.org/officeDocument/2006/relationships">
+  <p:cSld>
+    <p:spTree>
+      <p:nvGrpSpPr>
+        <p:cNvPr id="1" name=""/>
+        <p:cNvGrpSpPr/>
+        <p:nvPr/>
+      </p:nvGrpSpPr>
+      <p:grpSpPr>
+        <a:xfrm>
+          <a:off x="0" y="0"/>
+          <a:ext cx="0" cy="0"/>
+          <a:chOff x="0" y="0"/>
+          <a:chExt cx="0" cy="0"/>
+        </a:xfrm>
+      </p:grpSpPr>
+      <p:sp>
+        <p:nvSpPr>
+          <p:cNvPr id="2" name="Slide Image Placeholder 1"/>
+          <p:cNvSpPr>
+            <a:spLocks noGrp="1"/>
+          </p:cNvSpPr>
+          <p:nvPr>
+            <p:ph type="sldImg" idx="2"/>
+          </p:nvPr>
+        </p:nvSpPr>
+        <p:spPr/>
+      </p:sp>
+      <p:sp>
+        <p:nvSpPr>
+          <p:cNvPr id="3" name="Notes Placeholder 2"/>
+          <p:cNvSpPr>
+            <a:spLocks noGrp="1"/>
+          </p:cNvSpPr>
+          <p:nvPr>
+            <p:ph type="body" idx="3" sz="quarter"/>
+          </p:nvPr>
+        </p:nvSpPr>
+        <p:spPr/>
+        <p:txBody>
+          <a:bodyPr/>
+          <a:lstStyle/>
+          <a:p>
+            <a:r>
+              <a:t>【 SLIDE 19 】 Bagaimana Prosedur Server Down &amp; Mitigasi Komplain?</a:t>
             </a:r>
           </a:p>
           <a:p>
@@ -1717,11 +1953,7 @@
               <a:t>Pada evolusi produk terbaru kami, KostKu memperkenalkan AI Vision Room Scanner dan 3D Isometric Cutaway Viewer.</a:t>
             </a:r>
           </a:p>
-          <a:p>
-            <a:r>
-              <a:t>    </a:t>
-            </a:r>
-          </a:p>
+          <a:p/>
           <a:p>
             <a:r>
               <a:t>Pemilik kos tidak perlu memiliki keahlian arsitektur untuk membuat denah. Cukup unggah foto kamar, dan AI akan memindai ruang serta mengajukan kuesioner interaktif perabot—mulai dari ukuran kasur single hingga king size, AC, hingga kamar mandi dalam—lalu men-generate model 3D interaktif yang dapat diputar 4 sudut pandang dengan mode siang dan malam.</a:t>
@@ -5685,6 +5917,90 @@
       <p:pic>
         <p:nvPicPr>
           <p:cNvPr id="2" name="Picture 1" descr="slide_pptx_page-17.png"/>
+          <p:cNvPicPr>
+            <a:picLocks noChangeAspect="1"/>
+          </p:cNvPicPr>
+          <p:nvPr/>
+        </p:nvPicPr>
+        <p:blipFill>
+          <a:blip r:embed="rId2"/>
+          <a:stretch>
+            <a:fillRect/>
+          </a:stretch>
+        </p:blipFill>
+        <p:spPr>
+          <a:xfrm>
+            <a:off x="0" y="0"/>
+            <a:ext cx="12191695" cy="6858000"/>
+          </a:xfrm>
+          <a:prstGeom prst="rect">
+            <a:avLst/>
+          </a:prstGeom>
+        </p:spPr>
+      </p:pic>
+    </p:spTree>
+  </p:cSld>
+  <p:clrMapOvr>
+    <a:masterClrMapping/>
+  </p:clrMapOvr>
+</p:sld>
+</file>
+
+<file path=ppt/slides/slide18.xml><?xml version="1.0" encoding="utf-8"?>
+<p:sld xmlns:a="http://schemas.openxmlformats.org/drawingml/2006/main" xmlns:p="http://schemas.openxmlformats.org/presentationml/2006/main" xmlns:r="http://schemas.openxmlformats.org/officeDocument/2006/relationships">
+  <p:cSld>
+    <p:spTree>
+      <p:nvGrpSpPr>
+        <p:cNvPr id="1" name=""/>
+        <p:cNvGrpSpPr/>
+        <p:nvPr/>
+      </p:nvGrpSpPr>
+      <p:grpSpPr/>
+      <p:pic>
+        <p:nvPicPr>
+          <p:cNvPr id="2" name="Picture 1" descr="slide_pptx_page-18.png"/>
+          <p:cNvPicPr>
+            <a:picLocks noChangeAspect="1"/>
+          </p:cNvPicPr>
+          <p:nvPr/>
+        </p:nvPicPr>
+        <p:blipFill>
+          <a:blip r:embed="rId2"/>
+          <a:stretch>
+            <a:fillRect/>
+          </a:stretch>
+        </p:blipFill>
+        <p:spPr>
+          <a:xfrm>
+            <a:off x="0" y="0"/>
+            <a:ext cx="12191695" cy="6858000"/>
+          </a:xfrm>
+          <a:prstGeom prst="rect">
+            <a:avLst/>
+          </a:prstGeom>
+        </p:spPr>
+      </p:pic>
+    </p:spTree>
+  </p:cSld>
+  <p:clrMapOvr>
+    <a:masterClrMapping/>
+  </p:clrMapOvr>
+</p:sld>
+</file>
+
+<file path=ppt/slides/slide19.xml><?xml version="1.0" encoding="utf-8"?>
+<p:sld xmlns:a="http://schemas.openxmlformats.org/drawingml/2006/main" xmlns:p="http://schemas.openxmlformats.org/presentationml/2006/main" xmlns:r="http://schemas.openxmlformats.org/officeDocument/2006/relationships">
+  <p:cSld>
+    <p:spTree>
+      <p:nvGrpSpPr>
+        <p:cNvPr id="1" name=""/>
+        <p:cNvGrpSpPr/>
+        <p:nvPr/>
+      </p:nvGrpSpPr>
+      <p:grpSpPr/>
+      <p:pic>
+        <p:nvPicPr>
+          <p:cNvPr id="2" name="Picture 1" descr="slide_pptx_page-19.png"/>
           <p:cNvPicPr>
             <a:picLocks noChangeAspect="1"/>
           </p:cNvPicPr>

</xml_diff>